<commit_message>
Fill photo areas in photo-led carousel and Did you know cover with library photos
Co-Authored-By: Claude Sonnet 5.5 <noreply@anthropic.com>
Claude-Session: https://claude.ai/code/session_011Ayydt3bbwxJJGtBUdBGUR
</commit_message>
<xml_diff>
--- a/templates/carousels/did-you-know.pptx
+++ b/templates/carousels/did-you-know.pptx
@@ -506,7 +506,7 @@
           <a:lstStyle/>
           <a:p>
             <a:r>
-              <a:t>Cover. Fact must have a named source before posting. Nerdy and specific is the goal.</a:t>
+              <a:t>Cover. Photo: assets/microscopy/fungal-spores-in-suspension.jpg (brightfield soil sample: round spores and short bacterial rods). Swap to match the fact. Fact must have a named source before posting.</a:t>
             </a:r>
           </a:p>
         </p:txBody>
@@ -3800,12 +3800,20 @@
         <p:nvPr/>
       </p:nvGrpSpPr>
       <p:grpSpPr/>
-      <p:sp>
-        <p:nvSpPr>
-          <p:cNvPr id="2" name="Rectangle 1"/>
-          <p:cNvSpPr/>
+      <p:pic>
+        <p:nvPicPr>
+          <p:cNvPr id="2" name="Picture 1" descr="3389834300660306573.jpg"/>
+          <p:cNvPicPr>
+            <a:picLocks noChangeAspect="1"/>
+          </p:cNvPicPr>
           <p:nvPr/>
-        </p:nvSpPr>
+        </p:nvPicPr>
+        <p:blipFill>
+          <a:blip r:embed="rId3"/>
+          <a:stretch>
+            <a:fillRect/>
+          </a:stretch>
+        </p:blipFill>
         <p:spPr>
           <a:xfrm>
             <a:off x="0" y="0"/>
@@ -3814,86 +3822,11 @@
           <a:prstGeom prst="rect">
             <a:avLst/>
           </a:prstGeom>
-          <a:solidFill>
-            <a:srgbClr val="22371F"/>
-          </a:solidFill>
-          <a:ln>
-            <a:noFill/>
-          </a:ln>
-          <a:effectLst/>
-        </p:spPr>
-        <p:style>
-          <a:lnRef idx="1">
-            <a:schemeClr val="accent1"/>
-          </a:lnRef>
-          <a:fillRef idx="3">
-            <a:schemeClr val="accent1"/>
-          </a:fillRef>
-          <a:effectRef idx="2">
-            <a:schemeClr val="accent1"/>
-          </a:effectRef>
-          <a:fontRef idx="minor">
-            <a:schemeClr val="lt1"/>
-          </a:fontRef>
-        </p:style>
-        <p:txBody>
-          <a:bodyPr rtlCol="0" anchor="ctr"/>
-          <a:lstStyle/>
-          <a:p>
-            <a:pPr algn="ctr"/>
-          </a:p>
-        </p:txBody>
-      </p:sp>
+        </p:spPr>
+      </p:pic>
       <p:sp>
         <p:nvSpPr>
           <p:cNvPr id="3" name="TextBox 2"/>
-          <p:cNvSpPr txBox="1"/>
-          <p:nvPr/>
-        </p:nvSpPr>
-        <p:spPr>
-          <a:xfrm>
-            <a:off x="190500" y="0"/>
-            <a:ext cx="9906000" cy="6096000"/>
-          </a:xfrm>
-          <a:prstGeom prst="rect">
-            <a:avLst/>
-          </a:prstGeom>
-          <a:noFill/>
-        </p:spPr>
-        <p:txBody>
-          <a:bodyPr wrap="square" lIns="0" rIns="0" tIns="0" bIns="0" anchor="ctr">
-            <a:spAutoFit/>
-          </a:bodyPr>
-          <a:lstStyle/>
-          <a:p>
-            <a:pPr algn="ctr"/>
-            <a:r>
-              <a:rPr sz="2250" b="1" i="0">
-                <a:solidFill>
-                  <a:srgbClr val="DBE6A7"/>
-                </a:solidFill>
-                <a:latin typeface="Montserrat"/>
-              </a:rPr>
-              <a:t>[PHOTO: Microscope image (assets/microscopy/)]</a:t>
-            </a:r>
-          </a:p>
-          <a:p>
-            <a:pPr algn="ctr"/>
-            <a:r>
-              <a:rPr sz="2250" b="1" i="0">
-                <a:solidFill>
-                  <a:srgbClr val="DBE6A7"/>
-                </a:solidFill>
-                <a:latin typeface="Montserrat"/>
-              </a:rPr>
-              <a:t>Right-click, Change Picture. Only real SFW photos, with consent.</a:t>
-            </a:r>
-          </a:p>
-        </p:txBody>
-      </p:sp>
-      <p:sp>
-        <p:nvSpPr>
-          <p:cNvPr id="4" name="TextBox 3"/>
           <p:cNvSpPr txBox="1"/>
           <p:nvPr/>
         </p:nvSpPr>
@@ -3928,7 +3861,7 @@
       </p:sp>
       <p:sp>
         <p:nvSpPr>
-          <p:cNvPr id="5" name="TextBox 4"/>
+          <p:cNvPr id="4" name="TextBox 3"/>
           <p:cNvSpPr txBox="1"/>
           <p:nvPr/>
         </p:nvSpPr>
@@ -3967,7 +3900,7 @@
       </p:sp>
       <p:sp>
         <p:nvSpPr>
-          <p:cNvPr id="6" name="TextBox 5"/>
+          <p:cNvPr id="5" name="TextBox 4"/>
           <p:cNvSpPr txBox="1"/>
           <p:nvPr/>
         </p:nvSpPr>
@@ -4002,7 +3935,7 @@
       </p:sp>
       <p:sp>
         <p:nvSpPr>
-          <p:cNvPr id="7" name="Oval 6"/>
+          <p:cNvPr id="6" name="Oval 5"/>
           <p:cNvSpPr/>
           <p:nvPr/>
         </p:nvSpPr>
@@ -4046,7 +3979,7 @@
       </p:sp>
       <p:sp>
         <p:nvSpPr>
-          <p:cNvPr id="8" name="Oval 7"/>
+          <p:cNvPr id="7" name="Oval 6"/>
           <p:cNvSpPr/>
           <p:nvPr/>
         </p:nvSpPr>
@@ -4090,7 +4023,7 @@
       </p:sp>
       <p:sp>
         <p:nvSpPr>
-          <p:cNvPr id="9" name="Oval 8"/>
+          <p:cNvPr id="8" name="Oval 7"/>
           <p:cNvSpPr/>
           <p:nvPr/>
         </p:nvSpPr>
@@ -4134,7 +4067,7 @@
       </p:sp>
       <p:sp>
         <p:nvSpPr>
-          <p:cNvPr id="10" name="Oval 9"/>
+          <p:cNvPr id="9" name="Oval 8"/>
           <p:cNvSpPr/>
           <p:nvPr/>
         </p:nvSpPr>
@@ -4178,7 +4111,7 @@
       </p:sp>
       <p:sp>
         <p:nvSpPr>
-          <p:cNvPr id="11" name="Oval 10"/>
+          <p:cNvPr id="10" name="Oval 9"/>
           <p:cNvSpPr/>
           <p:nvPr/>
         </p:nvSpPr>

</xml_diff>

<commit_message>
Phone-readable type: 40px minimum for labels, 76px for body, shorter placeholder lines
Co-Authored-By: Claude Sonnet 5.5 <noreply@anthropic.com>
Claude-Session: https://claude.ai/code/session_011Ayydt3bbwxJJGtBUdBGUR
</commit_message>
<xml_diff>
--- a/templates/carousels/did-you-know.pptx
+++ b/templates/carousels/did-you-know.pptx
@@ -3802,7 +3802,7 @@
       <p:grpSpPr/>
       <p:pic>
         <p:nvPicPr>
-          <p:cNvPr id="2" name="Picture 1" descr="148730491744321056.jpg"/>
+          <p:cNvPr id="2" name="Picture 1" descr="4451056446361893579.jpg"/>
           <p:cNvPicPr>
             <a:picLocks noChangeAspect="1"/>
           </p:cNvPicPr>
@@ -3833,7 +3833,7 @@
         <p:spPr>
           <a:xfrm>
             <a:off x="571500" y="6381750"/>
-            <a:ext cx="6667500" cy="381000"/>
+            <a:ext cx="9144000" cy="381000"/>
           </a:xfrm>
           <a:prstGeom prst="rect">
             <a:avLst/>
@@ -3848,7 +3848,7 @@
           <a:p>
             <a:pPr algn="l"/>
             <a:r>
-              <a:rPr sz="2100" b="1" i="0">
+              <a:rPr sz="3000" b="1" i="0">
                 <a:solidFill>
                   <a:srgbClr val="DBE6A7"/>
                 </a:solidFill>
@@ -3887,13 +3887,13 @@
               </a:lnSpc>
             </a:pPr>
             <a:r>
-              <a:rPr sz="3750" b="1" i="0">
+              <a:rPr sz="5700" b="1" i="0">
                 <a:solidFill>
                   <a:srgbClr val="FFFFFF"/>
                 </a:solidFill>
                 <a:latin typeface="Montserrat"/>
               </a:rPr>
-              <a:t>[COPY: Allison] One surprising fact, specific and nerdy. Name the organism or the molecule.</a:t>
+              <a:t>[COPY: Allison] One surprising fact. Name the organism.</a:t>
             </a:r>
           </a:p>
         </p:txBody>
@@ -3922,7 +3922,7 @@
           <a:p>
             <a:pPr algn="l"/>
             <a:r>
-              <a:rPr sz="2100" b="1" i="0">
+              <a:rPr sz="3000" b="1" i="0">
                 <a:solidFill>
                   <a:srgbClr val="DBE6A7"/>
                 </a:solidFill>
@@ -4203,7 +4203,7 @@
           <a:p>
             <a:pPr algn="l"/>
             <a:r>
-              <a:rPr sz="2100" b="1" i="0">
+              <a:rPr sz="3000" b="1" i="0">
                 <a:solidFill>
                   <a:srgbClr val="156826"/>
                 </a:solidFill>
@@ -4284,7 +4284,7 @@
           <a:p>
             <a:pPr algn="ctr"/>
             <a:r>
-              <a:rPr sz="2400" b="1" i="0">
+              <a:rPr sz="3000" b="1" i="0">
                 <a:solidFill>
                   <a:srgbClr val="6A665C"/>
                 </a:solidFill>
@@ -4296,7 +4296,7 @@
           <a:p>
             <a:pPr algn="ctr"/>
             <a:r>
-              <a:rPr sz="2400" b="1" i="0">
+              <a:rPr sz="3000" b="1" i="0">
                 <a:solidFill>
                   <a:srgbClr val="6A665C"/>
                 </a:solidFill>
@@ -4335,13 +4335,13 @@
               </a:lnSpc>
             </a:pPr>
             <a:r>
-              <a:rPr sz="4050" b="0" i="0">
+              <a:rPr sz="5700" b="0" i="0">
                 <a:solidFill>
                   <a:srgbClr val="22371F"/>
                 </a:solidFill>
                 <a:latin typeface="EB Garamond"/>
               </a:rPr>
-              <a:t>[COPY: Allison] First step of the mechanism, one line. Name the organism, enzyme or compound.</a:t>
+              <a:t>[COPY: Allison] Step one, one line.</a:t>
             </a:r>
           </a:p>
         </p:txBody>
@@ -4370,13 +4370,13 @@
           <a:p>
             <a:pPr algn="l"/>
             <a:r>
-              <a:rPr sz="1950" b="0" i="0">
+              <a:rPr sz="3000" b="0" i="0">
                 <a:solidFill>
                   <a:srgbClr val="6A665C"/>
                 </a:solidFill>
                 <a:latin typeface="Source Sans 3"/>
               </a:rPr>
-              <a:t>[COPY: Allison] Source line: who measured it, where, which year. No source, no number.</a:t>
+              <a:t>[COPY: Allison] Source: who, where, year.</a:t>
             </a:r>
           </a:p>
         </p:txBody>
@@ -4405,7 +4405,7 @@
           <a:p>
             <a:pPr algn="l"/>
             <a:r>
-              <a:rPr sz="2100" b="1" i="0">
+              <a:rPr sz="3000" b="1" i="0">
                 <a:solidFill>
                   <a:srgbClr val="6A665C"/>
                 </a:solidFill>
@@ -4686,7 +4686,7 @@
           <a:p>
             <a:pPr algn="l"/>
             <a:r>
-              <a:rPr sz="2100" b="1" i="0">
+              <a:rPr sz="3000" b="1" i="0">
                 <a:solidFill>
                   <a:srgbClr val="156826"/>
                 </a:solidFill>
@@ -4767,7 +4767,7 @@
           <a:p>
             <a:pPr algn="ctr"/>
             <a:r>
-              <a:rPr sz="2400" b="1" i="0">
+              <a:rPr sz="3000" b="1" i="0">
                 <a:solidFill>
                   <a:srgbClr val="6A665C"/>
                 </a:solidFill>
@@ -4779,7 +4779,7 @@
           <a:p>
             <a:pPr algn="ctr"/>
             <a:r>
-              <a:rPr sz="2400" b="1" i="0">
+              <a:rPr sz="3000" b="1" i="0">
                 <a:solidFill>
                   <a:srgbClr val="6A665C"/>
                 </a:solidFill>
@@ -4818,13 +4818,13 @@
               </a:lnSpc>
             </a:pPr>
             <a:r>
-              <a:rPr sz="4050" b="0" i="0">
+              <a:rPr sz="5700" b="0" i="0">
                 <a:solidFill>
                   <a:srgbClr val="22371F"/>
                 </a:solidFill>
                 <a:latin typeface="EB Garamond"/>
               </a:rPr>
-              <a:t>[COPY: Allison] Second step, one line. Chemical or microbial level: what moves, what is released.</a:t>
+              <a:t>[COPY: Allison] Step two, one line.</a:t>
             </a:r>
           </a:p>
         </p:txBody>
@@ -4853,13 +4853,13 @@
           <a:p>
             <a:pPr algn="l"/>
             <a:r>
-              <a:rPr sz="1950" b="0" i="0">
+              <a:rPr sz="3000" b="0" i="0">
                 <a:solidFill>
                   <a:srgbClr val="6A665C"/>
                 </a:solidFill>
                 <a:latin typeface="Source Sans 3"/>
               </a:rPr>
-              <a:t>[COPY: Allison] Source line: who measured it, where, which year. No source, no number.</a:t>
+              <a:t>[COPY: Allison] Source: who, where, year.</a:t>
             </a:r>
           </a:p>
         </p:txBody>
@@ -4888,7 +4888,7 @@
           <a:p>
             <a:pPr algn="l"/>
             <a:r>
-              <a:rPr sz="2100" b="1" i="0">
+              <a:rPr sz="3000" b="1" i="0">
                 <a:solidFill>
                   <a:srgbClr val="6A665C"/>
                 </a:solidFill>
@@ -5169,7 +5169,7 @@
           <a:p>
             <a:pPr algn="l"/>
             <a:r>
-              <a:rPr sz="2100" b="1" i="0">
+              <a:rPr sz="3000" b="1" i="0">
                 <a:solidFill>
                   <a:srgbClr val="156826"/>
                 </a:solidFill>
@@ -5250,7 +5250,7 @@
           <a:p>
             <a:pPr algn="ctr"/>
             <a:r>
-              <a:rPr sz="2400" b="1" i="0">
+              <a:rPr sz="3000" b="1" i="0">
                 <a:solidFill>
                   <a:srgbClr val="6A665C"/>
                 </a:solidFill>
@@ -5262,7 +5262,7 @@
           <a:p>
             <a:pPr algn="ctr"/>
             <a:r>
-              <a:rPr sz="2400" b="1" i="0">
+              <a:rPr sz="3000" b="1" i="0">
                 <a:solidFill>
                   <a:srgbClr val="6A665C"/>
                 </a:solidFill>
@@ -5301,13 +5301,13 @@
               </a:lnSpc>
             </a:pPr>
             <a:r>
-              <a:rPr sz="4050" b="0" i="0">
+              <a:rPr sz="5700" b="0" i="0">
                 <a:solidFill>
                   <a:srgbClr val="22371F"/>
                 </a:solidFill>
                 <a:latin typeface="EB Garamond"/>
               </a:rPr>
-              <a:t>[COPY: Allison] Third step, one line. Where it ends up: in the soil, in the root, in the plant.</a:t>
+              <a:t>[COPY: Allison] Step three, one line.</a:t>
             </a:r>
           </a:p>
         </p:txBody>
@@ -5336,13 +5336,13 @@
           <a:p>
             <a:pPr algn="l"/>
             <a:r>
-              <a:rPr sz="1950" b="0" i="0">
+              <a:rPr sz="3000" b="0" i="0">
                 <a:solidFill>
                   <a:srgbClr val="6A665C"/>
                 </a:solidFill>
                 <a:latin typeface="Source Sans 3"/>
               </a:rPr>
-              <a:t>[COPY: Allison] Source line: who measured it, where, which year. No source, no number.</a:t>
+              <a:t>[COPY: Allison] Source: who, where, year.</a:t>
             </a:r>
           </a:p>
         </p:txBody>
@@ -5371,7 +5371,7 @@
           <a:p>
             <a:pPr algn="l"/>
             <a:r>
-              <a:rPr sz="2100" b="1" i="0">
+              <a:rPr sz="3000" b="1" i="0">
                 <a:solidFill>
                   <a:srgbClr val="6A665C"/>
                 </a:solidFill>
@@ -5637,7 +5637,7 @@
         <p:spPr>
           <a:xfrm>
             <a:off x="571500" y="571500"/>
-            <a:ext cx="8572500" cy="381000"/>
+            <a:ext cx="9144000" cy="381000"/>
           </a:xfrm>
           <a:prstGeom prst="rect">
             <a:avLst/>
@@ -5652,7 +5652,7 @@
           <a:p>
             <a:pPr algn="l"/>
             <a:r>
-              <a:rPr sz="2250" b="1" i="0">
+              <a:rPr sz="3000" b="1" i="0">
                 <a:solidFill>
                   <a:srgbClr val="DBE6A7"/>
                 </a:solidFill>
@@ -5691,13 +5691,13 @@
               </a:lnSpc>
             </a:pPr>
             <a:r>
-              <a:rPr sz="5400" b="1" i="0">
+              <a:rPr sz="5700" b="1" i="0">
                 <a:solidFill>
                   <a:srgbClr val="FFFFFF"/>
                 </a:solidFill>
                 <a:latin typeface="Montserrat"/>
               </a:rPr>
-              <a:t>[COPY: Allison] One line. What the reader can now look for or do on their own ground.</a:t>
+              <a:t>[COPY: Allison] One line for their own soil.</a:t>
             </a:r>
           </a:p>
         </p:txBody>
@@ -5726,13 +5726,13 @@
           <a:p>
             <a:pPr algn="l"/>
             <a:r>
-              <a:rPr sz="2700" b="0" i="1">
+              <a:rPr sz="5700" b="0" i="1">
                 <a:solidFill>
                   <a:srgbClr val="DBE6A7"/>
                 </a:solidFill>
                 <a:latin typeface="EB Garamond"/>
               </a:rPr>
-              <a:t>[COPY: Allison] One call to action only, or none.</a:t>
+              <a:t>[COPY: Allison] One call to action, or none.</a:t>
             </a:r>
           </a:p>
         </p:txBody>
@@ -5761,7 +5761,7 @@
           <a:p>
             <a:pPr algn="l"/>
             <a:r>
-              <a:rPr sz="2100" b="1" i="0">
+              <a:rPr sz="3000" b="1" i="0">
                 <a:solidFill>
                   <a:srgbClr val="A7B097"/>
                 </a:solidFill>

</xml_diff>

<commit_message>
Week 1 posts: World Teachers' Day five mentors and Carla Portugal, with captions and open items; stickers on dated posts
Co-Authored-By: Claude Sonnet 5.5 <noreply@anthropic.com>
Claude-Session: https://claude.ai/code/session_011Ayydt3bbwxJJGtBUdBGUR
</commit_message>
<xml_diff>
--- a/templates/carousels/did-you-know.pptx
+++ b/templates/carousels/did-you-know.pptx
@@ -3802,7 +3802,7 @@
       <p:grpSpPr/>
       <p:pic>
         <p:nvPicPr>
-          <p:cNvPr id="2" name="Picture 1" descr="4451056446361893579.jpg"/>
+          <p:cNvPr id="2" name="Picture 1" descr="4444114906578524514.jpg"/>
           <p:cNvPicPr>
             <a:picLocks noChangeAspect="1"/>
           </p:cNvPicPr>
@@ -3898,9 +3898,33 @@
           </a:p>
         </p:txBody>
       </p:sp>
-      <p:sp>
-        <p:nvSpPr>
-          <p:cNvPr id="5" name="TextBox 4"/>
+      <p:pic>
+        <p:nvPicPr>
+          <p:cNvPr id="5" name="Picture 4" descr="st4703964084880291919.png"/>
+          <p:cNvPicPr>
+            <a:picLocks noChangeAspect="1"/>
+          </p:cNvPicPr>
+          <p:nvPr/>
+        </p:nvPicPr>
+        <p:blipFill>
+          <a:blip r:embed="rId4"/>
+          <a:stretch>
+            <a:fillRect/>
+          </a:stretch>
+        </p:blipFill>
+        <p:spPr>
+          <a:xfrm rot="480000">
+            <a:off x="6667500" y="4476750"/>
+            <a:ext cx="4038600" cy="3028950"/>
+          </a:xfrm>
+          <a:prstGeom prst="rect">
+            <a:avLst/>
+          </a:prstGeom>
+        </p:spPr>
+      </p:pic>
+      <p:sp>
+        <p:nvSpPr>
+          <p:cNvPr id="6" name="TextBox 5"/>
           <p:cNvSpPr txBox="1"/>
           <p:nvPr/>
         </p:nvSpPr>
@@ -3935,7 +3959,7 @@
       </p:sp>
       <p:sp>
         <p:nvSpPr>
-          <p:cNvPr id="6" name="Oval 5"/>
+          <p:cNvPr id="7" name="Oval 6"/>
           <p:cNvSpPr/>
           <p:nvPr/>
         </p:nvSpPr>
@@ -3979,7 +4003,7 @@
       </p:sp>
       <p:sp>
         <p:nvSpPr>
-          <p:cNvPr id="7" name="Oval 6"/>
+          <p:cNvPr id="8" name="Oval 7"/>
           <p:cNvSpPr/>
           <p:nvPr/>
         </p:nvSpPr>
@@ -4023,7 +4047,7 @@
       </p:sp>
       <p:sp>
         <p:nvSpPr>
-          <p:cNvPr id="8" name="Oval 7"/>
+          <p:cNvPr id="9" name="Oval 8"/>
           <p:cNvSpPr/>
           <p:nvPr/>
         </p:nvSpPr>
@@ -4067,7 +4091,7 @@
       </p:sp>
       <p:sp>
         <p:nvSpPr>
-          <p:cNvPr id="9" name="Oval 8"/>
+          <p:cNvPr id="10" name="Oval 9"/>
           <p:cNvSpPr/>
           <p:nvPr/>
         </p:nvSpPr>
@@ -4111,7 +4135,7 @@
       </p:sp>
       <p:sp>
         <p:nvSpPr>
-          <p:cNvPr id="10" name="Oval 9"/>
+          <p:cNvPr id="11" name="Oval 10"/>
           <p:cNvSpPr/>
           <p:nvPr/>
         </p:nvSpPr>
@@ -4381,9 +4405,33 @@
           </a:p>
         </p:txBody>
       </p:sp>
-      <p:sp>
-        <p:nvSpPr>
-          <p:cNvPr id="7" name="TextBox 6"/>
+      <p:pic>
+        <p:nvPicPr>
+          <p:cNvPr id="7" name="Picture 6" descr="st2398059889886313316.png"/>
+          <p:cNvPicPr>
+            <a:picLocks noChangeAspect="1"/>
+          </p:cNvPicPr>
+          <p:nvPr/>
+        </p:nvPicPr>
+        <p:blipFill>
+          <a:blip r:embed="rId3"/>
+          <a:stretch>
+            <a:fillRect/>
+          </a:stretch>
+        </p:blipFill>
+        <p:spPr>
+          <a:xfrm rot="21240000">
+            <a:off x="6572250" y="5334000"/>
+            <a:ext cx="3943350" cy="2962275"/>
+          </a:xfrm>
+          <a:prstGeom prst="rect">
+            <a:avLst/>
+          </a:prstGeom>
+        </p:spPr>
+      </p:pic>
+      <p:sp>
+        <p:nvSpPr>
+          <p:cNvPr id="8" name="TextBox 7"/>
           <p:cNvSpPr txBox="1"/>
           <p:nvPr/>
         </p:nvSpPr>
@@ -4418,7 +4466,7 @@
       </p:sp>
       <p:sp>
         <p:nvSpPr>
-          <p:cNvPr id="8" name="Oval 7"/>
+          <p:cNvPr id="9" name="Oval 8"/>
           <p:cNvSpPr/>
           <p:nvPr/>
         </p:nvSpPr>
@@ -4462,7 +4510,7 @@
       </p:sp>
       <p:sp>
         <p:nvSpPr>
-          <p:cNvPr id="9" name="Oval 8"/>
+          <p:cNvPr id="10" name="Oval 9"/>
           <p:cNvSpPr/>
           <p:nvPr/>
         </p:nvSpPr>
@@ -4506,7 +4554,7 @@
       </p:sp>
       <p:sp>
         <p:nvSpPr>
-          <p:cNvPr id="10" name="Oval 9"/>
+          <p:cNvPr id="11" name="Oval 10"/>
           <p:cNvSpPr/>
           <p:nvPr/>
         </p:nvSpPr>
@@ -4550,7 +4598,7 @@
       </p:sp>
       <p:sp>
         <p:nvSpPr>
-          <p:cNvPr id="11" name="Oval 10"/>
+          <p:cNvPr id="12" name="Oval 11"/>
           <p:cNvSpPr/>
           <p:nvPr/>
         </p:nvSpPr>
@@ -4594,7 +4642,7 @@
       </p:sp>
       <p:sp>
         <p:nvSpPr>
-          <p:cNvPr id="12" name="Oval 11"/>
+          <p:cNvPr id="13" name="Oval 12"/>
           <p:cNvSpPr/>
           <p:nvPr/>
         </p:nvSpPr>
@@ -4864,9 +4912,33 @@
           </a:p>
         </p:txBody>
       </p:sp>
-      <p:sp>
-        <p:nvSpPr>
-          <p:cNvPr id="7" name="TextBox 6"/>
+      <p:pic>
+        <p:nvPicPr>
+          <p:cNvPr id="7" name="Picture 6" descr="st7229242836553501809.png"/>
+          <p:cNvPicPr>
+            <a:picLocks noChangeAspect="1"/>
+          </p:cNvPicPr>
+          <p:nvPr/>
+        </p:nvPicPr>
+        <p:blipFill>
+          <a:blip r:embed="rId3"/>
+          <a:stretch>
+            <a:fillRect/>
+          </a:stretch>
+        </p:blipFill>
+        <p:spPr>
+          <a:xfrm rot="420000">
+            <a:off x="6572250" y="5334000"/>
+            <a:ext cx="3943350" cy="2962275"/>
+          </a:xfrm>
+          <a:prstGeom prst="rect">
+            <a:avLst/>
+          </a:prstGeom>
+        </p:spPr>
+      </p:pic>
+      <p:sp>
+        <p:nvSpPr>
+          <p:cNvPr id="8" name="TextBox 7"/>
           <p:cNvSpPr txBox="1"/>
           <p:nvPr/>
         </p:nvSpPr>
@@ -4901,7 +4973,7 @@
       </p:sp>
       <p:sp>
         <p:nvSpPr>
-          <p:cNvPr id="8" name="Oval 7"/>
+          <p:cNvPr id="9" name="Oval 8"/>
           <p:cNvSpPr/>
           <p:nvPr/>
         </p:nvSpPr>
@@ -4945,7 +5017,7 @@
       </p:sp>
       <p:sp>
         <p:nvSpPr>
-          <p:cNvPr id="9" name="Oval 8"/>
+          <p:cNvPr id="10" name="Oval 9"/>
           <p:cNvSpPr/>
           <p:nvPr/>
         </p:nvSpPr>
@@ -4989,7 +5061,7 @@
       </p:sp>
       <p:sp>
         <p:nvSpPr>
-          <p:cNvPr id="10" name="Oval 9"/>
+          <p:cNvPr id="11" name="Oval 10"/>
           <p:cNvSpPr/>
           <p:nvPr/>
         </p:nvSpPr>
@@ -5033,7 +5105,7 @@
       </p:sp>
       <p:sp>
         <p:nvSpPr>
-          <p:cNvPr id="11" name="Oval 10"/>
+          <p:cNvPr id="12" name="Oval 11"/>
           <p:cNvSpPr/>
           <p:nvPr/>
         </p:nvSpPr>
@@ -5077,7 +5149,7 @@
       </p:sp>
       <p:sp>
         <p:nvSpPr>
-          <p:cNvPr id="12" name="Oval 11"/>
+          <p:cNvPr id="13" name="Oval 12"/>
           <p:cNvSpPr/>
           <p:nvPr/>
         </p:nvSpPr>
@@ -5347,9 +5419,33 @@
           </a:p>
         </p:txBody>
       </p:sp>
-      <p:sp>
-        <p:nvSpPr>
-          <p:cNvPr id="7" name="TextBox 6"/>
+      <p:pic>
+        <p:nvPicPr>
+          <p:cNvPr id="7" name="Picture 6" descr="st3911960079040886591.png"/>
+          <p:cNvPicPr>
+            <a:picLocks noChangeAspect="1"/>
+          </p:cNvPicPr>
+          <p:nvPr/>
+        </p:nvPicPr>
+        <p:blipFill>
+          <a:blip r:embed="rId3"/>
+          <a:stretch>
+            <a:fillRect/>
+          </a:stretch>
+        </p:blipFill>
+        <p:spPr>
+          <a:xfrm rot="21120000">
+            <a:off x="6572250" y="5334000"/>
+            <a:ext cx="3943350" cy="2962275"/>
+          </a:xfrm>
+          <a:prstGeom prst="rect">
+            <a:avLst/>
+          </a:prstGeom>
+        </p:spPr>
+      </p:pic>
+      <p:sp>
+        <p:nvSpPr>
+          <p:cNvPr id="8" name="TextBox 7"/>
           <p:cNvSpPr txBox="1"/>
           <p:nvPr/>
         </p:nvSpPr>
@@ -5384,7 +5480,7 @@
       </p:sp>
       <p:sp>
         <p:nvSpPr>
-          <p:cNvPr id="8" name="Oval 7"/>
+          <p:cNvPr id="9" name="Oval 8"/>
           <p:cNvSpPr/>
           <p:nvPr/>
         </p:nvSpPr>
@@ -5428,7 +5524,7 @@
       </p:sp>
       <p:sp>
         <p:nvSpPr>
-          <p:cNvPr id="9" name="Oval 8"/>
+          <p:cNvPr id="10" name="Oval 9"/>
           <p:cNvSpPr/>
           <p:nvPr/>
         </p:nvSpPr>
@@ -5472,7 +5568,7 @@
       </p:sp>
       <p:sp>
         <p:nvSpPr>
-          <p:cNvPr id="10" name="Oval 9"/>
+          <p:cNvPr id="11" name="Oval 10"/>
           <p:cNvSpPr/>
           <p:nvPr/>
         </p:nvSpPr>
@@ -5516,7 +5612,7 @@
       </p:sp>
       <p:sp>
         <p:nvSpPr>
-          <p:cNvPr id="11" name="Oval 10"/>
+          <p:cNvPr id="12" name="Oval 11"/>
           <p:cNvSpPr/>
           <p:nvPr/>
         </p:nvSpPr>
@@ -5560,7 +5656,7 @@
       </p:sp>
       <p:sp>
         <p:nvSpPr>
-          <p:cNvPr id="12" name="Oval 11"/>
+          <p:cNvPr id="13" name="Oval 12"/>
           <p:cNvSpPr/>
           <p:nvPr/>
         </p:nvSpPr>
@@ -5737,9 +5833,33 @@
           </a:p>
         </p:txBody>
       </p:sp>
-      <p:sp>
-        <p:nvSpPr>
-          <p:cNvPr id="5" name="TextBox 4"/>
+      <p:pic>
+        <p:nvPicPr>
+          <p:cNvPr id="5" name="Picture 4" descr="st7242593602918937377.png"/>
+          <p:cNvPicPr>
+            <a:picLocks noChangeAspect="1"/>
+          </p:cNvPicPr>
+          <p:nvPr/>
+        </p:nvPicPr>
+        <p:blipFill>
+          <a:blip r:embed="rId3"/>
+          <a:stretch>
+            <a:fillRect/>
+          </a:stretch>
+        </p:blipFill>
+        <p:spPr>
+          <a:xfrm rot="21240000">
+            <a:off x="5715000" y="8382000"/>
+            <a:ext cx="4800600" cy="3552825"/>
+          </a:xfrm>
+          <a:prstGeom prst="rect">
+            <a:avLst/>
+          </a:prstGeom>
+        </p:spPr>
+      </p:pic>
+      <p:sp>
+        <p:nvSpPr>
+          <p:cNvPr id="6" name="TextBox 5"/>
           <p:cNvSpPr txBox="1"/>
           <p:nvPr/>
         </p:nvSpPr>
@@ -5774,7 +5894,7 @@
       </p:sp>
       <p:sp>
         <p:nvSpPr>
-          <p:cNvPr id="6" name="Oval 5"/>
+          <p:cNvPr id="7" name="Oval 6"/>
           <p:cNvSpPr/>
           <p:nvPr/>
         </p:nvSpPr>
@@ -5818,7 +5938,7 @@
       </p:sp>
       <p:sp>
         <p:nvSpPr>
-          <p:cNvPr id="7" name="Oval 6"/>
+          <p:cNvPr id="8" name="Oval 7"/>
           <p:cNvSpPr/>
           <p:nvPr/>
         </p:nvSpPr>
@@ -5862,7 +5982,7 @@
       </p:sp>
       <p:sp>
         <p:nvSpPr>
-          <p:cNvPr id="8" name="Oval 7"/>
+          <p:cNvPr id="9" name="Oval 8"/>
           <p:cNvSpPr/>
           <p:nvPr/>
         </p:nvSpPr>
@@ -5906,7 +6026,7 @@
       </p:sp>
       <p:sp>
         <p:nvSpPr>
-          <p:cNvPr id="9" name="Oval 8"/>
+          <p:cNvPr id="10" name="Oval 9"/>
           <p:cNvSpPr/>
           <p:nvPr/>
         </p:nvSpPr>
@@ -5950,7 +6070,7 @@
       </p:sp>
       <p:sp>
         <p:nvSpPr>
-          <p:cNvPr id="10" name="Oval 9"/>
+          <p:cNvPr id="11" name="Oval 10"/>
           <p:cNvSpPr/>
           <p:nvPr/>
         </p:nvSpPr>

</xml_diff>

<commit_message>
Dated posts named DD-MM-YYYY; rebuild with larger type; Oct 5 slot is the Teachers' Day post
Co-Authored-By: Claude Sonnet 5.5 <noreply@anthropic.com>
Claude-Session: https://claude.ai/code/session_011Ayydt3bbwxJJGtBUdBGUR
</commit_message>
<xml_diff>
--- a/templates/carousels/did-you-know.pptx
+++ b/templates/carousels/did-you-know.pptx
@@ -3802,7 +3802,7 @@
       <p:grpSpPr/>
       <p:pic>
         <p:nvPicPr>
-          <p:cNvPr id="2" name="Picture 1" descr="4444114906578524514.jpg"/>
+          <p:cNvPr id="2" name="Picture 1" descr="56620256649884338.jpg"/>
           <p:cNvPicPr>
             <a:picLocks noChangeAspect="1"/>
           </p:cNvPicPr>
@@ -3900,7 +3900,7 @@
       </p:sp>
       <p:pic>
         <p:nvPicPr>
-          <p:cNvPr id="5" name="Picture 4" descr="st4703964084880291919.png"/>
+          <p:cNvPr id="5" name="Picture 4" descr="st2639853730536920197.png"/>
           <p:cNvPicPr>
             <a:picLocks noChangeAspect="1"/>
           </p:cNvPicPr>
@@ -4407,7 +4407,7 @@
       </p:sp>
       <p:pic>
         <p:nvPicPr>
-          <p:cNvPr id="7" name="Picture 6" descr="st2398059889886313316.png"/>
+          <p:cNvPr id="7" name="Picture 6" descr="st282452605729079137.png"/>
           <p:cNvPicPr>
             <a:picLocks noChangeAspect="1"/>
           </p:cNvPicPr>
@@ -4914,7 +4914,7 @@
       </p:sp>
       <p:pic>
         <p:nvPicPr>
-          <p:cNvPr id="7" name="Picture 6" descr="st7229242836553501809.png"/>
+          <p:cNvPr id="7" name="Picture 6" descr="st7206700200716447276.png"/>
           <p:cNvPicPr>
             <a:picLocks noChangeAspect="1"/>
           </p:cNvPicPr>
@@ -5421,7 +5421,7 @@
       </p:sp>
       <p:pic>
         <p:nvPicPr>
-          <p:cNvPr id="7" name="Picture 6" descr="st3911960079040886591.png"/>
+          <p:cNvPr id="7" name="Picture 6" descr="st7130489339427790111.png"/>
           <p:cNvPicPr>
             <a:picLocks noChangeAspect="1"/>
           </p:cNvPicPr>
@@ -5835,7 +5835,7 @@
       </p:sp>
       <p:pic>
         <p:nvPicPr>
-          <p:cNvPr id="5" name="Picture 4" descr="st7242593602918937377.png"/>
+          <p:cNvPr id="5" name="Picture 4" descr="st8191692115093855546.png"/>
           <p:cNvPicPr>
             <a:picLocks noChangeAspect="1"/>
           </p:cNvPicPr>

</xml_diff>

<commit_message>
Use the real brand palette from Canva (green #31662F, cream #F3F1EA, brown #4C3634, sage #B1BCB1, gold #D39C48)
</commit_message>
<xml_diff>
--- a/templates/carousels/did-you-know.pptx
+++ b/templates/carousels/did-you-know.pptx
@@ -3802,7 +3802,7 @@
       <p:grpSpPr/>
       <p:pic>
         <p:nvPicPr>
-          <p:cNvPr id="2" name="Picture 1" descr="56620256649884338.jpg"/>
+          <p:cNvPr id="2" name="Picture 1" descr="7723909191706000921.jpg"/>
           <p:cNvPicPr>
             <a:picLocks noChangeAspect="1"/>
           </p:cNvPicPr>
@@ -3850,7 +3850,7 @@
             <a:r>
               <a:rPr sz="3000" b="1" i="0">
                 <a:solidFill>
-                  <a:srgbClr val="DBE6A7"/>
+                  <a:srgbClr val="B1BCB1"/>
                 </a:solidFill>
                 <a:latin typeface="Montserrat"/>
               </a:rPr>
@@ -3900,7 +3900,7 @@
       </p:sp>
       <p:pic>
         <p:nvPicPr>
-          <p:cNvPr id="5" name="Picture 4" descr="st2639853730536920197.png"/>
+          <p:cNvPr id="5" name="Picture 4" descr="st2558467560971008754.png"/>
           <p:cNvPicPr>
             <a:picLocks noChangeAspect="1"/>
           </p:cNvPicPr>
@@ -3948,7 +3948,7 @@
             <a:r>
               <a:rPr sz="3000" b="1" i="0">
                 <a:solidFill>
-                  <a:srgbClr val="DBE6A7"/>
+                  <a:srgbClr val="B1BCB1"/>
                 </a:solidFill>
                 <a:latin typeface="Montserrat"/>
               </a:rPr>
@@ -3972,7 +3972,7 @@
             <a:avLst/>
           </a:prstGeom>
           <a:solidFill>
-            <a:srgbClr val="DBE6A7"/>
+            <a:srgbClr val="B1BCB1"/>
           </a:solidFill>
           <a:ln>
             <a:noFill/>
@@ -4016,7 +4016,7 @@
             <a:avLst/>
           </a:prstGeom>
           <a:solidFill>
-            <a:srgbClr val="22371F"/>
+            <a:srgbClr val="1E3F1D"/>
           </a:solidFill>
           <a:ln>
             <a:noFill/>
@@ -4060,7 +4060,7 @@
             <a:avLst/>
           </a:prstGeom>
           <a:solidFill>
-            <a:srgbClr val="22371F"/>
+            <a:srgbClr val="1E3F1D"/>
           </a:solidFill>
           <a:ln>
             <a:noFill/>
@@ -4104,7 +4104,7 @@
             <a:avLst/>
           </a:prstGeom>
           <a:solidFill>
-            <a:srgbClr val="22371F"/>
+            <a:srgbClr val="1E3F1D"/>
           </a:solidFill>
           <a:ln>
             <a:noFill/>
@@ -4148,7 +4148,7 @@
             <a:avLst/>
           </a:prstGeom>
           <a:solidFill>
-            <a:srgbClr val="22371F"/>
+            <a:srgbClr val="1E3F1D"/>
           </a:solidFill>
           <a:ln>
             <a:noFill/>
@@ -4191,7 +4191,7 @@
     <p:bg>
       <p:bgPr>
         <a:solidFill>
-          <a:srgbClr val="F4F1EA"/>
+          <a:srgbClr val="F3F1EA"/>
         </a:solidFill>
         <a:effectLst/>
       </p:bgPr>
@@ -4229,7 +4229,7 @@
             <a:r>
               <a:rPr sz="3000" b="1" i="0">
                 <a:solidFill>
-                  <a:srgbClr val="156826"/>
+                  <a:srgbClr val="31662F"/>
                 </a:solidFill>
                 <a:latin typeface="Montserrat"/>
               </a:rPr>
@@ -4257,7 +4257,7 @@
           </a:solidFill>
           <a:ln w="28575">
             <a:solidFill>
-              <a:srgbClr val="A7B097"/>
+              <a:srgbClr val="B1BCB1"/>
             </a:solidFill>
           </a:ln>
           <a:effectLst/>
@@ -4361,7 +4361,7 @@
             <a:r>
               <a:rPr sz="5700" b="0" i="0">
                 <a:solidFill>
-                  <a:srgbClr val="22371F"/>
+                  <a:srgbClr val="1E3F1D"/>
                 </a:solidFill>
                 <a:latin typeface="EB Garamond"/>
               </a:rPr>
@@ -4407,7 +4407,7 @@
       </p:sp>
       <p:pic>
         <p:nvPicPr>
-          <p:cNvPr id="7" name="Picture 6" descr="st282452605729079137.png"/>
+          <p:cNvPr id="7" name="Picture 6" descr="st7144803508716543224.png"/>
           <p:cNvPicPr>
             <a:picLocks noChangeAspect="1"/>
           </p:cNvPicPr>
@@ -4479,7 +4479,7 @@
             <a:avLst/>
           </a:prstGeom>
           <a:solidFill>
-            <a:srgbClr val="A7B097"/>
+            <a:srgbClr val="B1BCB1"/>
           </a:solidFill>
           <a:ln>
             <a:noFill/>
@@ -4523,7 +4523,7 @@
             <a:avLst/>
           </a:prstGeom>
           <a:solidFill>
-            <a:srgbClr val="156826"/>
+            <a:srgbClr val="31662F"/>
           </a:solidFill>
           <a:ln>
             <a:noFill/>
@@ -4567,7 +4567,7 @@
             <a:avLst/>
           </a:prstGeom>
           <a:solidFill>
-            <a:srgbClr val="A7B097"/>
+            <a:srgbClr val="B1BCB1"/>
           </a:solidFill>
           <a:ln>
             <a:noFill/>
@@ -4611,7 +4611,7 @@
             <a:avLst/>
           </a:prstGeom>
           <a:solidFill>
-            <a:srgbClr val="A7B097"/>
+            <a:srgbClr val="B1BCB1"/>
           </a:solidFill>
           <a:ln>
             <a:noFill/>
@@ -4655,7 +4655,7 @@
             <a:avLst/>
           </a:prstGeom>
           <a:solidFill>
-            <a:srgbClr val="A7B097"/>
+            <a:srgbClr val="B1BCB1"/>
           </a:solidFill>
           <a:ln>
             <a:noFill/>
@@ -4698,7 +4698,7 @@
     <p:bg>
       <p:bgPr>
         <a:solidFill>
-          <a:srgbClr val="F4F1EA"/>
+          <a:srgbClr val="F3F1EA"/>
         </a:solidFill>
         <a:effectLst/>
       </p:bgPr>
@@ -4736,7 +4736,7 @@
             <a:r>
               <a:rPr sz="3000" b="1" i="0">
                 <a:solidFill>
-                  <a:srgbClr val="156826"/>
+                  <a:srgbClr val="31662F"/>
                 </a:solidFill>
                 <a:latin typeface="Montserrat"/>
               </a:rPr>
@@ -4764,7 +4764,7 @@
           </a:solidFill>
           <a:ln w="28575">
             <a:solidFill>
-              <a:srgbClr val="A7B097"/>
+              <a:srgbClr val="B1BCB1"/>
             </a:solidFill>
           </a:ln>
           <a:effectLst/>
@@ -4868,7 +4868,7 @@
             <a:r>
               <a:rPr sz="5700" b="0" i="0">
                 <a:solidFill>
-                  <a:srgbClr val="22371F"/>
+                  <a:srgbClr val="1E3F1D"/>
                 </a:solidFill>
                 <a:latin typeface="EB Garamond"/>
               </a:rPr>
@@ -4914,7 +4914,7 @@
       </p:sp>
       <p:pic>
         <p:nvPicPr>
-          <p:cNvPr id="7" name="Picture 6" descr="st7206700200716447276.png"/>
+          <p:cNvPr id="7" name="Picture 6" descr="st2523896290647565520.png"/>
           <p:cNvPicPr>
             <a:picLocks noChangeAspect="1"/>
           </p:cNvPicPr>
@@ -4986,7 +4986,7 @@
             <a:avLst/>
           </a:prstGeom>
           <a:solidFill>
-            <a:srgbClr val="A7B097"/>
+            <a:srgbClr val="B1BCB1"/>
           </a:solidFill>
           <a:ln>
             <a:noFill/>
@@ -5030,7 +5030,7 @@
             <a:avLst/>
           </a:prstGeom>
           <a:solidFill>
-            <a:srgbClr val="A7B097"/>
+            <a:srgbClr val="B1BCB1"/>
           </a:solidFill>
           <a:ln>
             <a:noFill/>
@@ -5074,7 +5074,7 @@
             <a:avLst/>
           </a:prstGeom>
           <a:solidFill>
-            <a:srgbClr val="156826"/>
+            <a:srgbClr val="31662F"/>
           </a:solidFill>
           <a:ln>
             <a:noFill/>
@@ -5118,7 +5118,7 @@
             <a:avLst/>
           </a:prstGeom>
           <a:solidFill>
-            <a:srgbClr val="A7B097"/>
+            <a:srgbClr val="B1BCB1"/>
           </a:solidFill>
           <a:ln>
             <a:noFill/>
@@ -5162,7 +5162,7 @@
             <a:avLst/>
           </a:prstGeom>
           <a:solidFill>
-            <a:srgbClr val="A7B097"/>
+            <a:srgbClr val="B1BCB1"/>
           </a:solidFill>
           <a:ln>
             <a:noFill/>
@@ -5205,7 +5205,7 @@
     <p:bg>
       <p:bgPr>
         <a:solidFill>
-          <a:srgbClr val="F4F1EA"/>
+          <a:srgbClr val="F3F1EA"/>
         </a:solidFill>
         <a:effectLst/>
       </p:bgPr>
@@ -5243,7 +5243,7 @@
             <a:r>
               <a:rPr sz="3000" b="1" i="0">
                 <a:solidFill>
-                  <a:srgbClr val="156826"/>
+                  <a:srgbClr val="31662F"/>
                 </a:solidFill>
                 <a:latin typeface="Montserrat"/>
               </a:rPr>
@@ -5271,7 +5271,7 @@
           </a:solidFill>
           <a:ln w="28575">
             <a:solidFill>
-              <a:srgbClr val="A7B097"/>
+              <a:srgbClr val="B1BCB1"/>
             </a:solidFill>
           </a:ln>
           <a:effectLst/>
@@ -5375,7 +5375,7 @@
             <a:r>
               <a:rPr sz="5700" b="0" i="0">
                 <a:solidFill>
-                  <a:srgbClr val="22371F"/>
+                  <a:srgbClr val="1E3F1D"/>
                 </a:solidFill>
                 <a:latin typeface="EB Garamond"/>
               </a:rPr>
@@ -5421,7 +5421,7 @@
       </p:sp>
       <p:pic>
         <p:nvPicPr>
-          <p:cNvPr id="7" name="Picture 6" descr="st7130489339427790111.png"/>
+          <p:cNvPr id="7" name="Picture 6" descr="st4750798945456173185.png"/>
           <p:cNvPicPr>
             <a:picLocks noChangeAspect="1"/>
           </p:cNvPicPr>
@@ -5493,7 +5493,7 @@
             <a:avLst/>
           </a:prstGeom>
           <a:solidFill>
-            <a:srgbClr val="A7B097"/>
+            <a:srgbClr val="B1BCB1"/>
           </a:solidFill>
           <a:ln>
             <a:noFill/>
@@ -5537,7 +5537,7 @@
             <a:avLst/>
           </a:prstGeom>
           <a:solidFill>
-            <a:srgbClr val="A7B097"/>
+            <a:srgbClr val="B1BCB1"/>
           </a:solidFill>
           <a:ln>
             <a:noFill/>
@@ -5581,7 +5581,7 @@
             <a:avLst/>
           </a:prstGeom>
           <a:solidFill>
-            <a:srgbClr val="A7B097"/>
+            <a:srgbClr val="B1BCB1"/>
           </a:solidFill>
           <a:ln>
             <a:noFill/>
@@ -5625,7 +5625,7 @@
             <a:avLst/>
           </a:prstGeom>
           <a:solidFill>
-            <a:srgbClr val="156826"/>
+            <a:srgbClr val="31662F"/>
           </a:solidFill>
           <a:ln>
             <a:noFill/>
@@ -5669,7 +5669,7 @@
             <a:avLst/>
           </a:prstGeom>
           <a:solidFill>
-            <a:srgbClr val="A7B097"/>
+            <a:srgbClr val="B1BCB1"/>
           </a:solidFill>
           <a:ln>
             <a:noFill/>
@@ -5712,7 +5712,7 @@
     <p:bg>
       <p:bgPr>
         <a:solidFill>
-          <a:srgbClr val="22371F"/>
+          <a:srgbClr val="1E3F1D"/>
         </a:solidFill>
         <a:effectLst/>
       </p:bgPr>
@@ -5750,7 +5750,7 @@
             <a:r>
               <a:rPr sz="3000" b="1" i="0">
                 <a:solidFill>
-                  <a:srgbClr val="DBE6A7"/>
+                  <a:srgbClr val="B1BCB1"/>
                 </a:solidFill>
                 <a:latin typeface="Montserrat"/>
               </a:rPr>
@@ -5824,7 +5824,7 @@
             <a:r>
               <a:rPr sz="5700" b="0" i="1">
                 <a:solidFill>
-                  <a:srgbClr val="DBE6A7"/>
+                  <a:srgbClr val="B1BCB1"/>
                 </a:solidFill>
                 <a:latin typeface="EB Garamond"/>
               </a:rPr>
@@ -5835,7 +5835,7 @@
       </p:sp>
       <p:pic>
         <p:nvPicPr>
-          <p:cNvPr id="5" name="Picture 4" descr="st8191692115093855546.png"/>
+          <p:cNvPr id="5" name="Picture 4" descr="st7730167352228561430.png"/>
           <p:cNvPicPr>
             <a:picLocks noChangeAspect="1"/>
           </p:cNvPicPr>
@@ -5883,7 +5883,7 @@
             <a:r>
               <a:rPr sz="3000" b="1" i="0">
                 <a:solidFill>
-                  <a:srgbClr val="A7B097"/>
+                  <a:srgbClr val="B1BCB1"/>
                 </a:solidFill>
                 <a:latin typeface="Montserrat"/>
               </a:rPr>
@@ -6083,7 +6083,7 @@
             <a:avLst/>
           </a:prstGeom>
           <a:solidFill>
-            <a:srgbClr val="DBE6A7"/>
+            <a:srgbClr val="B1BCB1"/>
           </a:solidFill>
           <a:ln>
             <a:noFill/>

</xml_diff>